<commit_message>
update requirements to include mlflow and replace final presentation file. ADD spike prediction module and mlflow for spike prediction.
</commit_message>
<xml_diff>
--- a/artifact/presentation/v3_final_v2/final_presentationv2_with_images.pptx
+++ b/artifact/presentation/v3_final_v2/final_presentationv2_with_images.pptx
@@ -13741,8 +13741,8 @@
         </p:nvSpPr>
         <p:spPr>
           <a:xfrm>
-            <a:off x="640080" y="1371600"/>
-            <a:ext cx="5120640" cy="365760"/>
+            <a:off x="640080" y="1483381"/>
+            <a:ext cx="5120640" cy="646331"/>
           </a:xfrm>
           <a:prstGeom prst="rect">
             <a:avLst/>
@@ -13757,13 +13757,34 @@
           <a:p>
             <a:pPr algn="l"/>
             <a:r>
-              <a:rPr sz="1800" b="1">
+              <a:rPr lang="en-US" altLang="ko-KR" b="1" dirty="0">
                 <a:solidFill>
                   <a:srgbClr val="FFFFFF"/>
                 </a:solidFill>
                 <a:latin typeface="Calibri"/>
               </a:rPr>
-              <a:t>Spatio-Temporal Cross-Validation</a:t>
+              <a:t>Improve the model performance with</a:t>
+            </a:r>
+          </a:p>
+          <a:p>
+            <a:pPr algn="l"/>
+            <a:r>
+              <a:rPr lang="en-US" altLang="ko-KR" b="1" dirty="0" err="1">
+                <a:solidFill>
+                  <a:srgbClr val="FFFFFF"/>
+                </a:solidFill>
+                <a:latin typeface="Calibri"/>
+              </a:rPr>
+              <a:t>Spatio</a:t>
+            </a:r>
+            <a:r>
+              <a:rPr lang="en-US" altLang="ko-KR" b="1" dirty="0">
+                <a:solidFill>
+                  <a:srgbClr val="FFFFFF"/>
+                </a:solidFill>
+                <a:latin typeface="Calibri"/>
+              </a:rPr>
+              <a:t>/temporal cross validation</a:t>
             </a:r>
           </a:p>
         </p:txBody>
@@ -13776,8 +13797,8 @@
         </p:nvSpPr>
         <p:spPr>
           <a:xfrm>
-            <a:off x="640080" y="1828800"/>
-            <a:ext cx="5120640" cy="1371600"/>
+            <a:off x="640080" y="2212399"/>
+            <a:ext cx="5120640" cy="512961"/>
           </a:xfrm>
           <a:prstGeom prst="rect">
             <a:avLst/>
@@ -13796,7 +13817,7 @@
               </a:spcAft>
             </a:pPr>
             <a:r>
-              <a:rPr sz="1200" b="0">
+              <a:rPr sz="1200" b="0" dirty="0">
                 <a:solidFill>
                   <a:srgbClr val="B0B8C8"/>
                 </a:solidFill>
@@ -13812,7 +13833,7 @@
               </a:spcAft>
             </a:pPr>
             <a:r>
-              <a:rPr sz="1200" b="0">
+              <a:rPr sz="1200" b="0" dirty="0">
                 <a:solidFill>
                   <a:srgbClr val="B0B8C8"/>
                 </a:solidFill>
@@ -13820,67 +13841,12 @@
               </a:rPr>
               <a:t>Temporal:  Expanding window (3 folds)</a:t>
             </a:r>
-          </a:p>
-          <a:p>
-            <a:pPr algn="l">
-              <a:spcAft>
-                <a:spcPts val="400"/>
-              </a:spcAft>
-            </a:pPr>
-            <a:r>
-              <a:rPr sz="1200" b="0">
-                <a:solidFill>
-                  <a:srgbClr val="5CD68A"/>
-                </a:solidFill>
-                <a:latin typeface="Calibri"/>
-              </a:rPr>
-              <a:t>Combined:  5 x 3 = 15 fold combos per target x horizon</a:t>
-            </a:r>
-          </a:p>
-          <a:p>
-            <a:pPr algn="l">
-              <a:spcAft>
-                <a:spcPts val="400"/>
-              </a:spcAft>
-            </a:pPr>
-            <a:endParaRPr sz="1200" b="0">
+            <a:endParaRPr lang="ko-KR" altLang="en-US" sz="1200" b="0" dirty="0">
               <a:solidFill>
-                <a:srgbClr val="5CD68A"/>
+                <a:srgbClr val="B0B8C8"/>
               </a:solidFill>
               <a:latin typeface="Calibri"/>
             </a:endParaRPr>
-          </a:p>
-          <a:p>
-            <a:pPr algn="l">
-              <a:spcAft>
-                <a:spcPts val="400"/>
-              </a:spcAft>
-            </a:pPr>
-            <a:r>
-              <a:rPr sz="1100" b="0">
-                <a:solidFill>
-                  <a:srgbClr val="8A94AD"/>
-                </a:solidFill>
-                <a:latin typeface="Calibri"/>
-              </a:rPr>
-              <a:t>Prevents spatial autocorrelation leakage</a:t>
-            </a:r>
-          </a:p>
-          <a:p>
-            <a:pPr algn="l">
-              <a:spcAft>
-                <a:spcPts val="400"/>
-              </a:spcAft>
-            </a:pPr>
-            <a:r>
-              <a:rPr sz="1100" b="0">
-                <a:solidFill>
-                  <a:srgbClr val="8A94AD"/>
-                </a:solidFill>
-                <a:latin typeface="Calibri"/>
-              </a:rPr>
-              <a:t>and temporal information leakage simultaneously</a:t>
-            </a:r>
           </a:p>
         </p:txBody>
       </p:sp>
@@ -14266,7 +14232,7 @@
           <a:p>
             <a:pPr algn="l"/>
             <a:r>
-              <a:rPr sz="1800" b="1">
+              <a:rPr sz="1800" b="1" dirty="0">
                 <a:solidFill>
                   <a:srgbClr val="FFFFFF"/>
                 </a:solidFill>
@@ -14305,13 +14271,22 @@
               </a:spcAft>
             </a:pPr>
             <a:r>
-              <a:rPr sz="1300" b="1">
+              <a:rPr sz="1300" b="1" dirty="0" err="1">
                 <a:solidFill>
                   <a:srgbClr val="4E9AF5"/>
                 </a:solidFill>
                 <a:latin typeface="Calibri"/>
               </a:rPr>
-              <a:t>Spatio-Temporal CV Results</a:t>
+              <a:t>Spatio</a:t>
+            </a:r>
+            <a:r>
+              <a:rPr sz="1300" b="1" dirty="0">
+                <a:solidFill>
+                  <a:srgbClr val="4E9AF5"/>
+                </a:solidFill>
+                <a:latin typeface="Calibri"/>
+              </a:rPr>
+              <a:t>-Temporal CV Results</a:t>
             </a:r>
           </a:p>
           <a:p>
@@ -14320,7 +14295,7 @@
                 <a:spcPts val="400"/>
               </a:spcAft>
             </a:pPr>
-            <a:endParaRPr sz="1300" b="1">
+            <a:endParaRPr sz="1300" b="1" dirty="0">
               <a:solidFill>
                 <a:srgbClr val="4E9AF5"/>
               </a:solidFill>
@@ -14334,7 +14309,7 @@
               </a:spcAft>
             </a:pPr>
             <a:r>
-              <a:rPr sz="1200" b="0">
+              <a:rPr sz="1200" b="0" dirty="0">
                 <a:solidFill>
                   <a:srgbClr val="8A94AD"/>
                 </a:solidFill>
@@ -14350,7 +14325,7 @@
               </a:spcAft>
             </a:pPr>
             <a:r>
-              <a:rPr sz="1200" b="0">
+              <a:rPr sz="1200" b="0" dirty="0">
                 <a:solidFill>
                   <a:srgbClr val="8A94AD"/>
                 </a:solidFill>
@@ -14365,7 +14340,7 @@
                 <a:spcPts val="400"/>
               </a:spcAft>
             </a:pPr>
-            <a:endParaRPr sz="1200" b="0">
+            <a:endParaRPr sz="1200" b="0" dirty="0">
               <a:solidFill>
                 <a:srgbClr val="8A94AD"/>
               </a:solidFill>
@@ -14379,7 +14354,7 @@
               </a:spcAft>
             </a:pPr>
             <a:r>
-              <a:rPr sz="1300" b="1">
+              <a:rPr sz="1300" b="1" dirty="0">
                 <a:solidFill>
                   <a:srgbClr val="4E9AF5"/>
                 </a:solidFill>
@@ -14394,7 +14369,7 @@
                 <a:spcPts val="400"/>
               </a:spcAft>
             </a:pPr>
-            <a:endParaRPr sz="1300" b="1">
+            <a:endParaRPr sz="1300" b="1" dirty="0">
               <a:solidFill>
                 <a:srgbClr val="4E9AF5"/>
               </a:solidFill>
@@ -14408,7 +14383,7 @@
               </a:spcAft>
             </a:pPr>
             <a:r>
-              <a:rPr sz="1200" b="0">
+              <a:rPr sz="1200" b="0" dirty="0">
                 <a:solidFill>
                   <a:srgbClr val="8A94AD"/>
                 </a:solidFill>
@@ -14424,7 +14399,7 @@
               </a:spcAft>
             </a:pPr>
             <a:r>
-              <a:rPr sz="1200" b="0">
+              <a:rPr sz="1200" b="0" dirty="0">
                 <a:solidFill>
                   <a:srgbClr val="8A94AD"/>
                 </a:solidFill>
@@ -14439,7 +14414,7 @@
                 <a:spcPts val="400"/>
               </a:spcAft>
             </a:pPr>
-            <a:endParaRPr sz="1200" b="0">
+            <a:endParaRPr sz="1200" b="0" dirty="0">
               <a:solidFill>
                 <a:srgbClr val="8A94AD"/>
               </a:solidFill>
@@ -14453,7 +14428,7 @@
               </a:spcAft>
             </a:pPr>
             <a:r>
-              <a:rPr sz="1300" b="1">
+              <a:rPr sz="1300" b="1" dirty="0">
                 <a:solidFill>
                   <a:srgbClr val="4E9AF5"/>
                 </a:solidFill>
@@ -14468,7 +14443,7 @@
                 <a:spcPts val="400"/>
               </a:spcAft>
             </a:pPr>
-            <a:endParaRPr sz="1300" b="1">
+            <a:endParaRPr sz="1300" b="1" dirty="0">
               <a:solidFill>
                 <a:srgbClr val="4E9AF5"/>
               </a:solidFill>
@@ -14482,7 +14457,7 @@
               </a:spcAft>
             </a:pPr>
             <a:r>
-              <a:rPr sz="1200" b="0">
+              <a:rPr sz="1200" b="0" dirty="0">
                 <a:solidFill>
                   <a:srgbClr val="B0B8C8"/>
                 </a:solidFill>
@@ -14498,7 +14473,7 @@
               </a:spcAft>
             </a:pPr>
             <a:r>
-              <a:rPr sz="1200" b="0">
+              <a:rPr sz="1200" b="0" dirty="0">
                 <a:solidFill>
                   <a:srgbClr val="B0B8C8"/>
                 </a:solidFill>

</xml_diff>